<commit_message>
refresh of the programming DB deck
</commit_message>
<xml_diff>
--- a/modules/week06/slides-06.pptx
+++ b/modules/week06/slides-06.pptx
@@ -6,51 +6,45 @@
     <p:sldMasterId id="2147483673" r:id="rId2"/>
   </p:sldMasterIdLst>
   <p:notesMasterIdLst>
-    <p:notesMasterId r:id="rId7"/>
+    <p:notesMasterId r:id="rId8"/>
   </p:notesMasterIdLst>
   <p:sldIdLst>
     <p:sldId id="256" r:id="rId3"/>
     <p:sldId id="257" r:id="rId4"/>
     <p:sldId id="266" r:id="rId5"/>
     <p:sldId id="265" r:id="rId6"/>
+    <p:sldId id="267" r:id="rId7"/>
   </p:sldIdLst>
   <p:sldSz cx="9144000" cy="5143500" type="screen16x9"/>
   <p:notesSz cx="6858000" cy="9144000"/>
   <p:embeddedFontLst>
     <p:embeddedFont>
-      <p:font typeface="Avenir"/>
-      <p:regular r:id="rId8"/>
-      <p:italic r:id="rId9"/>
+      <p:font typeface="Avenir" panose="02000503020000020003" pitchFamily="2" charset="0"/>
+      <p:regular r:id="rId9"/>
+      <p:italic r:id="rId10"/>
     </p:embeddedFont>
     <p:embeddedFont>
-      <p:font typeface="Avenir Book" panose="02000503020000020003"/>
-      <p:regular r:id="rId10"/>
-      <p:italic r:id="rId11"/>
-    </p:embeddedFont>
-    <p:embeddedFont>
-      <p:font typeface="Calibri" panose="020F0502020204030204" pitchFamily="34" charset="0"/>
-      <p:regular r:id="rId12"/>
-      <p:bold r:id="rId13"/>
-      <p:italic r:id="rId14"/>
-      <p:boldItalic r:id="rId15"/>
+      <p:font typeface="Avenir Book" panose="02000503020000020003" pitchFamily="2" charset="0"/>
+      <p:regular r:id="rId11"/>
+      <p:italic r:id="rId12"/>
     </p:embeddedFont>
     <p:embeddedFont>
       <p:font typeface="Century Gothic" panose="020B0502020202020204" pitchFamily="34" charset="0"/>
-      <p:regular r:id="rId16"/>
-      <p:bold r:id="rId17"/>
-      <p:italic r:id="rId18"/>
-      <p:boldItalic r:id="rId19"/>
+      <p:regular r:id="rId13"/>
+      <p:bold r:id="rId14"/>
+      <p:italic r:id="rId15"/>
+      <p:boldItalic r:id="rId16"/>
     </p:embeddedFont>
     <p:embeddedFont>
-      <p:font typeface="Lobster"/>
-      <p:regular r:id="rId20"/>
+      <p:font typeface="Lobster" pitchFamily="2" charset="77"/>
+      <p:regular r:id="rId17"/>
     </p:embeddedFont>
     <p:embeddedFont>
-      <p:font typeface="Nunito Sans"/>
-      <p:regular r:id="rId21"/>
-      <p:bold r:id="rId22"/>
-      <p:italic r:id="rId23"/>
-      <p:boldItalic r:id="rId24"/>
+      <p:font typeface="Nunito Sans" pitchFamily="2" charset="77"/>
+      <p:regular r:id="rId18"/>
+      <p:bold r:id="rId19"/>
+      <p:italic r:id="rId20"/>
+      <p:boldItalic r:id="rId21"/>
     </p:embeddedFont>
   </p:embeddedFontLst>
   <p:defaultTextStyle>
@@ -1113,6 +1107,90 @@
     <p:extLst>
       <p:ext uri="{BB962C8B-B14F-4D97-AF65-F5344CB8AC3E}">
         <p14:creationId xmlns:p14="http://schemas.microsoft.com/office/powerpoint/2010/main" val="1904274571"/>
+      </p:ext>
+    </p:extLst>
+  </p:cSld>
+  <p:clrMapOvr>
+    <a:masterClrMapping/>
+  </p:clrMapOvr>
+</p:notes>
+</file>
+
+<file path=ppt/notesSlides/notesSlide5.xml><?xml version="1.0" encoding="utf-8"?>
+<p:notes xmlns:a="http://schemas.openxmlformats.org/drawingml/2006/main" xmlns:r="http://schemas.openxmlformats.org/officeDocument/2006/relationships" xmlns:p="http://schemas.openxmlformats.org/presentationml/2006/main">
+  <p:cSld>
+    <p:spTree>
+      <p:nvGrpSpPr>
+        <p:cNvPr id="1" name="">
+          <a:extLst>
+            <a:ext uri="{FF2B5EF4-FFF2-40B4-BE49-F238E27FC236}">
+              <a16:creationId xmlns:a16="http://schemas.microsoft.com/office/drawing/2014/main" id="{683487AF-FE53-78E0-0870-219EEC32C270}"/>
+            </a:ext>
+          </a:extLst>
+        </p:cNvPr>
+        <p:cNvGrpSpPr/>
+        <p:nvPr/>
+      </p:nvGrpSpPr>
+      <p:grpSpPr>
+        <a:xfrm>
+          <a:off x="0" y="0"/>
+          <a:ext cx="0" cy="0"/>
+          <a:chOff x="0" y="0"/>
+          <a:chExt cx="0" cy="0"/>
+        </a:xfrm>
+      </p:grpSpPr>
+      <p:sp>
+        <p:nvSpPr>
+          <p:cNvPr id="2" name="Slide Image Placeholder 1">
+            <a:extLst>
+              <a:ext uri="{FF2B5EF4-FFF2-40B4-BE49-F238E27FC236}">
+                <a16:creationId xmlns:a16="http://schemas.microsoft.com/office/drawing/2014/main" id="{ACFB929C-D358-BEA7-BD9D-13F2484DB511}"/>
+              </a:ext>
+            </a:extLst>
+          </p:cNvPr>
+          <p:cNvSpPr>
+            <a:spLocks noGrp="1" noRot="1" noChangeAspect="1"/>
+          </p:cNvSpPr>
+          <p:nvPr>
+            <p:ph type="sldImg"/>
+          </p:nvPr>
+        </p:nvSpPr>
+        <p:spPr>
+          <a:xfrm>
+            <a:off x="381000" y="685800"/>
+            <a:ext cx="6096000" cy="3429000"/>
+          </a:xfrm>
+        </p:spPr>
+      </p:sp>
+      <p:sp>
+        <p:nvSpPr>
+          <p:cNvPr id="3" name="Notes Placeholder 2">
+            <a:extLst>
+              <a:ext uri="{FF2B5EF4-FFF2-40B4-BE49-F238E27FC236}">
+                <a16:creationId xmlns:a16="http://schemas.microsoft.com/office/drawing/2014/main" id="{1DBEEA25-3C06-EF33-BB83-87055BB1E33D}"/>
+              </a:ext>
+            </a:extLst>
+          </p:cNvPr>
+          <p:cNvSpPr>
+            <a:spLocks noGrp="1"/>
+          </p:cNvSpPr>
+          <p:nvPr>
+            <p:ph type="body" idx="1"/>
+          </p:nvPr>
+        </p:nvSpPr>
+        <p:spPr/>
+        <p:txBody>
+          <a:bodyPr/>
+          <a:lstStyle/>
+          <a:p>
+            <a:endParaRPr lang="en-US" dirty="0"/>
+          </a:p>
+        </p:txBody>
+      </p:sp>
+    </p:spTree>
+    <p:extLst>
+      <p:ext uri="{BB962C8B-B14F-4D97-AF65-F5344CB8AC3E}">
+        <p14:creationId xmlns:p14="http://schemas.microsoft.com/office/powerpoint/2010/main" val="1824360873"/>
       </p:ext>
     </p:extLst>
   </p:cSld>
@@ -15346,7 +15424,14 @@
             <a:pPr lvl="1"/>
             <a:r>
               <a:rPr lang="en-US" dirty="0"/>
-              <a:t>Alternative to exporting data as CSV</a:t>
+              <a:t>Handle data larger than RAM</a:t>
+            </a:r>
+          </a:p>
+          <a:p>
+            <a:pPr lvl="1"/>
+            <a:r>
+              <a:rPr lang="en-US" dirty="0"/>
+              <a:t>Conduct more complex analysis, like modeling</a:t>
             </a:r>
           </a:p>
           <a:p>
@@ -15380,22 +15465,27 @@
           <a:p>
             <a:r>
               <a:rPr lang="en-US" dirty="0"/>
-              <a:t>Not:</a:t>
+              <a:t>Not best for:</a:t>
             </a:r>
           </a:p>
           <a:p>
             <a:pPr lvl="1"/>
             <a:r>
               <a:rPr lang="en-US" dirty="0"/>
-              <a:t>To explore data, data model</a:t>
+              <a:t>Creating data models / schema</a:t>
             </a:r>
           </a:p>
           <a:p>
             <a:pPr lvl="1"/>
             <a:r>
               <a:rPr lang="en-US" dirty="0"/>
-              <a:t>Manage data</a:t>
+              <a:t>Manage data </a:t>
             </a:r>
+            <a:r>
+              <a:rPr lang="en-US"/>
+              <a:t>(update / add / delete)</a:t>
+            </a:r>
+            <a:endParaRPr lang="en-US" dirty="0"/>
           </a:p>
         </p:txBody>
       </p:sp>
@@ -15550,7 +15640,7 @@
               <a:rPr lang="en-US" dirty="0">
                 <a:latin typeface="Avenir Book" panose="02000503020000020003" pitchFamily="2" charset="0"/>
               </a:rPr>
-              <a:t>Usually done once per program invocation</a:t>
+              <a:t>Usually done once per session </a:t>
             </a:r>
           </a:p>
           <a:p>
@@ -15697,6 +15787,185 @@
     <p:extLst>
       <p:ext uri="{BB962C8B-B14F-4D97-AF65-F5344CB8AC3E}">
         <p14:creationId xmlns:p14="http://schemas.microsoft.com/office/powerpoint/2010/main" val="363412015"/>
+      </p:ext>
+    </p:extLst>
+  </p:cSld>
+  <p:clrMapOvr>
+    <a:masterClrMapping/>
+  </p:clrMapOvr>
+</p:sld>
+</file>
+
+<file path=ppt/slides/slide5.xml><?xml version="1.0" encoding="utf-8"?>
+<p:sld xmlns:a="http://schemas.openxmlformats.org/drawingml/2006/main" xmlns:r="http://schemas.openxmlformats.org/officeDocument/2006/relationships" xmlns:p="http://schemas.openxmlformats.org/presentationml/2006/main">
+  <p:cSld>
+    <p:spTree>
+      <p:nvGrpSpPr>
+        <p:cNvPr id="1" name="">
+          <a:extLst>
+            <a:ext uri="{FF2B5EF4-FFF2-40B4-BE49-F238E27FC236}">
+              <a16:creationId xmlns:a16="http://schemas.microsoft.com/office/drawing/2014/main" id="{E3BA7A72-AD7B-2D02-E908-4BCF265BD044}"/>
+            </a:ext>
+          </a:extLst>
+        </p:cNvPr>
+        <p:cNvGrpSpPr/>
+        <p:nvPr/>
+      </p:nvGrpSpPr>
+      <p:grpSpPr>
+        <a:xfrm>
+          <a:off x="0" y="0"/>
+          <a:ext cx="0" cy="0"/>
+          <a:chOff x="0" y="0"/>
+          <a:chExt cx="0" cy="0"/>
+        </a:xfrm>
+      </p:grpSpPr>
+      <p:sp>
+        <p:nvSpPr>
+          <p:cNvPr id="2" name="Title 1">
+            <a:extLst>
+              <a:ext uri="{FF2B5EF4-FFF2-40B4-BE49-F238E27FC236}">
+                <a16:creationId xmlns:a16="http://schemas.microsoft.com/office/drawing/2014/main" id="{0202BCF7-A6DE-702F-A5C1-00E75AF3B467}"/>
+              </a:ext>
+            </a:extLst>
+          </p:cNvPr>
+          <p:cNvSpPr>
+            <a:spLocks noGrp="1"/>
+          </p:cNvSpPr>
+          <p:nvPr>
+            <p:ph type="title"/>
+          </p:nvPr>
+        </p:nvSpPr>
+        <p:spPr/>
+        <p:txBody>
+          <a:bodyPr/>
+          <a:lstStyle/>
+          <a:p>
+            <a:r>
+              <a:rPr lang="en-US" dirty="0" err="1"/>
+              <a:t>D</a:t>
+            </a:r>
+            <a:r>
+              <a:rPr lang="en-US" b="0" dirty="0" err="1"/>
+              <a:t>b</a:t>
+            </a:r>
+            <a:r>
+              <a:rPr lang="en-US" dirty="0" err="1"/>
+              <a:t>plyr</a:t>
+            </a:r>
+            <a:r>
+              <a:rPr lang="en-US" dirty="0"/>
+              <a:t> in R</a:t>
+            </a:r>
+          </a:p>
+        </p:txBody>
+      </p:sp>
+      <p:sp>
+        <p:nvSpPr>
+          <p:cNvPr id="3" name="Text Placeholder 2">
+            <a:extLst>
+              <a:ext uri="{FF2B5EF4-FFF2-40B4-BE49-F238E27FC236}">
+                <a16:creationId xmlns:a16="http://schemas.microsoft.com/office/drawing/2014/main" id="{CFE0D651-FE27-A3CB-4F13-CE54A1766EA0}"/>
+              </a:ext>
+            </a:extLst>
+          </p:cNvPr>
+          <p:cNvSpPr>
+            <a:spLocks noGrp="1"/>
+          </p:cNvSpPr>
+          <p:nvPr>
+            <p:ph type="body" idx="1"/>
+          </p:nvPr>
+        </p:nvSpPr>
+        <p:spPr/>
+        <p:txBody>
+          <a:bodyPr>
+            <a:normAutofit/>
+          </a:bodyPr>
+          <a:lstStyle/>
+          <a:p>
+            <a:pPr>
+              <a:spcBef>
+                <a:spcPts val="600"/>
+              </a:spcBef>
+            </a:pPr>
+            <a:r>
+              <a:rPr lang="en-US" sz="2400" dirty="0" err="1"/>
+              <a:t>Tidyverse</a:t>
+            </a:r>
+            <a:r>
+              <a:rPr lang="en-US" sz="2400" dirty="0"/>
+              <a:t> style code</a:t>
+            </a:r>
+          </a:p>
+          <a:p>
+            <a:pPr>
+              <a:spcBef>
+                <a:spcPts val="600"/>
+              </a:spcBef>
+            </a:pPr>
+            <a:r>
+              <a:rPr lang="en-US" sz="2400" dirty="0"/>
+              <a:t>Generates SQL in the background</a:t>
+            </a:r>
+          </a:p>
+          <a:p>
+            <a:pPr>
+              <a:spcBef>
+                <a:spcPts val="600"/>
+              </a:spcBef>
+            </a:pPr>
+            <a:r>
+              <a:rPr lang="en-US" sz="2400" dirty="0"/>
+              <a:t>Can make it very handy to switch from a data frame workflow to a database workflow</a:t>
+            </a:r>
+            <a:endParaRPr lang="en-US" sz="2400" dirty="0">
+              <a:latin typeface="Courier New" panose="02070309020205020404" pitchFamily="49" charset="0"/>
+              <a:cs typeface="Courier New" panose="02070309020205020404" pitchFamily="49" charset="0"/>
+            </a:endParaRPr>
+          </a:p>
+        </p:txBody>
+      </p:sp>
+      <p:sp>
+        <p:nvSpPr>
+          <p:cNvPr id="4" name="Slide Number Placeholder 3">
+            <a:extLst>
+              <a:ext uri="{FF2B5EF4-FFF2-40B4-BE49-F238E27FC236}">
+                <a16:creationId xmlns:a16="http://schemas.microsoft.com/office/drawing/2014/main" id="{A8D0A0C6-72EF-69A9-21E9-C9B66284DF7A}"/>
+              </a:ext>
+            </a:extLst>
+          </p:cNvPr>
+          <p:cNvSpPr>
+            <a:spLocks noGrp="1"/>
+          </p:cNvSpPr>
+          <p:nvPr>
+            <p:ph type="sldNum" idx="12"/>
+          </p:nvPr>
+        </p:nvSpPr>
+        <p:spPr/>
+        <p:txBody>
+          <a:bodyPr/>
+          <a:lstStyle/>
+          <a:p>
+            <a:pPr marL="0" lvl="0" indent="0" algn="r" rtl="0">
+              <a:spcBef>
+                <a:spcPts val="0"/>
+              </a:spcBef>
+              <a:spcAft>
+                <a:spcPts val="0"/>
+              </a:spcAft>
+              <a:buNone/>
+            </a:pPr>
+            <a:fld id="{00000000-1234-1234-1234-123412341234}" type="slidenum">
+              <a:rPr lang="en" smtClean="0"/>
+              <a:t>5</a:t>
+            </a:fld>
+            <a:endParaRPr lang="en" dirty="0"/>
+          </a:p>
+        </p:txBody>
+      </p:sp>
+    </p:spTree>
+    <p:extLst>
+      <p:ext uri="{BB962C8B-B14F-4D97-AF65-F5344CB8AC3E}">
+        <p14:creationId xmlns:p14="http://schemas.microsoft.com/office/powerpoint/2010/main" val="209533932"/>
       </p:ext>
     </p:extLst>
   </p:cSld>

</xml_diff>